<commit_message>
Nouvel exercice COL (Comparator et Comparable)
</commit_message>
<xml_diff>
--- a/_slides/slides_de_cours/09. COL_slides.pptx
+++ b/_slides/slides_de_cours/09. COL_slides.pptx
@@ -51,6 +51,7 @@
     <p:sldId id="613" r:id="rId39"/>
     <p:sldId id="614" r:id="rId40"/>
     <p:sldId id="616" r:id="rId41"/>
+    <p:sldId id="618" r:id="rId58"/>
     <p:sldId id="596" r:id="rId42"/>
     <p:sldId id="597" r:id="rId43"/>
     <p:sldId id="598" r:id="rId44"/>
@@ -9044,6 +9045,86 @@
           </p:cNvSpPr>
           <p:nvPr>
             <p:ph type="sldNum" sz="quarter" idx="5"/>
+          </p:nvPr>
+        </p:nvSpPr>
+        <p:spPr/>
+      </p:sp>
+    </p:spTree>
+  </p:cSld>
+  <p:clrMapOvr>
+    <a:masterClrMapping/>
+  </p:clrMapOvr>
+</p:notes>
+</file>
+
+<file path=ppt/notesSlides/notesSlide51.xml><?xml version="1.0" encoding="utf-8"?>
+<p:notes xmlns:a="http://schemas.openxmlformats.org/drawingml/2006/main" xmlns:p="http://schemas.openxmlformats.org/presentationml/2006/main" xmlns:r="http://schemas.openxmlformats.org/officeDocument/2006/relationships">
+  <p:cSld>
+    <p:spTree>
+      <p:nvGrpSpPr>
+        <p:cNvPr id="1" name=""/>
+        <p:cNvGrpSpPr/>
+        <p:nvPr/>
+      </p:nvGrpSpPr>
+      <p:grpSpPr>
+        <a:xfrm>
+          <a:off x="0" y="0"/>
+          <a:ext cx="0" cy="0"/>
+          <a:chOff x="0" y="0"/>
+          <a:chExt cx="0" cy="0"/>
+        </a:xfrm>
+      </p:grpSpPr>
+      <p:sp>
+        <p:nvSpPr>
+          <p:cNvPr id="2" name="Slide Image Placeholder 1"/>
+          <p:cNvSpPr>
+            <a:spLocks noGrp="1"/>
+          </p:cNvSpPr>
+          <p:nvPr>
+            <p:ph type="sldImg" idx="2"/>
+          </p:nvPr>
+        </p:nvSpPr>
+        <p:spPr/>
+      </p:sp>
+      <p:sp>
+        <p:nvSpPr>
+          <p:cNvPr id="3" name="Notes Placeholder 2"/>
+          <p:cNvSpPr>
+            <a:spLocks noGrp="1"/>
+          </p:cNvSpPr>
+          <p:nvPr>
+            <p:ph type="body" idx="3" sz="quarter"/>
+          </p:nvPr>
+        </p:nvSpPr>
+        <p:spPr/>
+        <p:txBody>
+          <a:bodyPr/>
+          <a:lstStyle/>
+          <a:p>
+            <a:r>
+              <a:t>COL.8 met en pratique toute la section : un record qui reçoit son ordre naturel par compareTo, deux comparateurs pour les autres ordres, et trois méthodes qui trient une copie de la liste.</a:t>
+            </a:r>
+          </a:p>
+          <a:p>
+            <a:r>
+              <a:t>Le piège à faire découvrir est dans la première question de l'énoncé : un TreeSet range ses éléments avec le comparateur, et considère comme doublons deux livres pour lesquels il retourne 0. Un comparateur par auteur seul ne garderait qu'un livre par auteur. Le second critère, le titre, n'est pas un détail.</a:t>
+            </a:r>
+          </a:p>
+          <a:p>
+            <a:r>
+              <a:t>Pour les années, Integer.compare plutôt qu'une soustraction : la note de bas de page du support montre le débordement. Au module LAM, ces deux comparateurs tiendront chacun en une ligne.</a:t>
+            </a:r>
+          </a:p>
+        </p:txBody>
+      </p:sp>
+      <p:sp>
+        <p:nvSpPr>
+          <p:cNvPr id="4" name="Slide Number Placeholder 3"/>
+          <p:cNvSpPr>
+            <a:spLocks noGrp="1"/>
+          </p:cNvSpPr>
+          <p:nvPr>
+            <p:ph type="sldNum" idx="5" sz="quarter"/>
           </p:nvPr>
         </p:nvSpPr>
         <p:spPr/>
@@ -40824,6 +40905,321 @@
       </p:par>
     </p:tnLst>
   </p:timing>
+</p:sld>
+</file>
+
+<file path=ppt/slides/slide51.xml><?xml version="1.0" encoding="utf-8"?>
+<p:sld xmlns:a="http://schemas.openxmlformats.org/drawingml/2006/main" xmlns:p="http://schemas.openxmlformats.org/presentationml/2006/main" xmlns:r="http://schemas.openxmlformats.org/officeDocument/2006/relationships">
+  <p:cSld>
+    <p:spTree>
+      <p:nvGrpSpPr>
+        <p:cNvPr id="1" name=""/>
+        <p:cNvGrpSpPr/>
+        <p:nvPr/>
+      </p:nvGrpSpPr>
+      <p:grpSpPr/>
+      <p:sp>
+        <p:nvSpPr>
+          <p:cNvPr id="2" name="Title 1"/>
+          <p:cNvSpPr>
+            <a:spLocks noGrp="1"/>
+          </p:cNvSpPr>
+          <p:nvPr>
+            <p:ph type="title"/>
+          </p:nvPr>
+        </p:nvSpPr>
+        <p:spPr/>
+        <p:txBody>
+          <a:bodyPr>
+            <a:noAutofit/>
+          </a:bodyPr>
+          <a:lstStyle/>
+          <a:p>
+            <a:r>
+              <a:rPr sz="4000"/>
+              <a:t>Exercices</a:t>
+            </a:r>
+          </a:p>
+        </p:txBody>
+      </p:sp>
+      <p:sp>
+        <p:nvSpPr>
+          <p:cNvPr id="3" name="Rounded Rectangle 2"/>
+          <p:cNvSpPr/>
+          <p:nvPr/>
+        </p:nvSpPr>
+        <p:spPr>
+          <a:xfrm>
+            <a:off x="640080" y="1417320"/>
+            <a:ext cx="9326880" cy="960120"/>
+          </a:xfrm>
+          <a:prstGeom prst="roundRect">
+            <a:avLst>
+              <a:gd name="adj" fmla="val 9523"/>
+            </a:avLst>
+          </a:prstGeom>
+          <a:solidFill>
+            <a:srgbClr val="1D1F22"/>
+          </a:solidFill>
+          <a:ln>
+            <a:noFill/>
+          </a:ln>
+          <a:effectLst>
+            <a:outerShdw blurRad="50800" dist="38100" dir="2700000" algn="tl" rotWithShape="0">
+              <a:prstClr val="black">
+                <a:alpha val="40000"/>
+              </a:prstClr>
+            </a:outerShdw>
+          </a:effectLst>
+        </p:spPr>
+        <p:style>
+          <a:lnRef idx="1">
+            <a:schemeClr val="accent1"/>
+          </a:lnRef>
+          <a:fillRef idx="3">
+            <a:schemeClr val="accent1"/>
+          </a:fillRef>
+          <a:effectRef idx="2">
+            <a:schemeClr val="accent1"/>
+          </a:effectRef>
+          <a:fontRef idx="minor">
+            <a:schemeClr val="lt1"/>
+          </a:fontRef>
+        </p:style>
+        <p:txBody>
+          <a:bodyPr rtlCol="0" anchor="ctr"/>
+          <a:lstStyle/>
+          <a:p>
+            <a:pPr algn="ctr"/>
+            <a:endParaRPr/>
+          </a:p>
+        </p:txBody>
+      </p:sp>
+      <p:sp>
+        <p:nvSpPr>
+          <p:cNvPr id="4" name="TextBox 3"/>
+          <p:cNvSpPr txBox="1"/>
+          <p:nvPr/>
+        </p:nvSpPr>
+        <p:spPr>
+          <a:xfrm>
+            <a:off x="868680" y="1417320"/>
+            <a:ext cx="1920240" cy="960120"/>
+          </a:xfrm>
+          <a:prstGeom prst="rect">
+            <a:avLst/>
+          </a:prstGeom>
+          <a:noFill/>
+        </p:spPr>
+        <p:txBody>
+          <a:bodyPr wrap="none" anchor="ctr">
+            <a:spAutoFit/>
+          </a:bodyPr>
+          <a:lstStyle/>
+          <a:p>
+            <a:r>
+              <a:rPr sz="3000" b="1">
+                <a:solidFill>
+                  <a:schemeClr val="accent4"/>
+                </a:solidFill>
+                <a:latin typeface="Consolas"/>
+              </a:rPr>
+              <a:t>COL.8</a:t>
+            </a:r>
+          </a:p>
+        </p:txBody>
+      </p:sp>
+      <p:sp>
+        <p:nvSpPr>
+          <p:cNvPr id="5" name="TextBox 4"/>
+          <p:cNvSpPr txBox="1"/>
+          <p:nvPr/>
+        </p:nvSpPr>
+        <p:spPr>
+          <a:xfrm>
+            <a:off x="2880360" y="1417320"/>
+            <a:ext cx="6949440" cy="960120"/>
+          </a:xfrm>
+          <a:prstGeom prst="rect">
+            <a:avLst/>
+          </a:prstGeom>
+          <a:noFill/>
+        </p:spPr>
+        <p:txBody>
+          <a:bodyPr wrap="square" anchor="ctr">
+            <a:spAutoFit/>
+          </a:bodyPr>
+          <a:lstStyle/>
+          <a:p>
+            <a:r>
+              <a:rPr sz="2800">
+                <a:solidFill>
+                  <a:srgbClr val="FFFFFF"/>
+                </a:solidFill>
+              </a:rPr>
+              <a:t>Trois ordres pour une bibliothèque</a:t>
+            </a:r>
+          </a:p>
+          <a:p>
+            <a:r>
+              <a:rPr sz="1400">
+                <a:solidFill>
+                  <a:srgbClr val="BCBEC4"/>
+                </a:solidFill>
+              </a:rPr>
+              <a:t>fascicule COL</a:t>
+            </a:r>
+          </a:p>
+        </p:txBody>
+      </p:sp>
+      <p:sp>
+        <p:nvSpPr>
+          <p:cNvPr id="6" name="TextBox 5"/>
+          <p:cNvSpPr txBox="1"/>
+          <p:nvPr/>
+        </p:nvSpPr>
+        <p:spPr>
+          <a:xfrm>
+            <a:off x="640080" y="2651760"/>
+            <a:ext cx="9326880" cy="822960"/>
+          </a:xfrm>
+          <a:prstGeom prst="rect">
+            <a:avLst/>
+          </a:prstGeom>
+          <a:noFill/>
+        </p:spPr>
+        <p:txBody>
+          <a:bodyPr wrap="square">
+            <a:spAutoFit/>
+          </a:bodyPr>
+          <a:lstStyle/>
+          <a:p>
+            <a:r>
+              <a:rPr sz="2400"/>
+              <a:t>Départager : </a:t>
+            </a:r>
+            <a:r>
+              <a:rPr sz="2400">
+                <a:solidFill>
+                  <a:schemeClr val="accent4"/>
+                </a:solidFill>
+                <a:latin typeface="Consolas"/>
+              </a:rPr>
+              <a:t>Integer.compare</a:t>
+            </a:r>
+            <a:r>
+              <a:rPr sz="2400"/>
+              <a:t>, jamais une soustraction</a:t>
+            </a:r>
+          </a:p>
+        </p:txBody>
+      </p:sp>
+      <p:pic>
+        <p:nvPicPr>
+          <p:cNvPr id="7" name="Picture 6" descr="image.png"/>
+          <p:cNvPicPr>
+            <a:picLocks noChangeAspect="1"/>
+          </p:cNvPicPr>
+          <p:nvPr/>
+        </p:nvPicPr>
+        <p:blipFill>
+          <a:blip r:embed="rId2" cstate="print">
+            <a:extLst>
+              <a:ext uri="{28A0092B-C50C-407E-A947-70E740481C1C}">
+                <a14:useLocalDpi xmlns:a14="http://schemas.microsoft.com/office/drawing/2010/main"/>
+              </a:ext>
+            </a:extLst>
+          </a:blip>
+          <a:stretch>
+            <a:fillRect/>
+          </a:stretch>
+        </p:blipFill>
+        <p:spPr>
+          <a:xfrm>
+            <a:off x="10332720" y="475488"/>
+            <a:ext cx="1280160" cy="1280160"/>
+          </a:xfrm>
+          <a:prstGeom prst="rect">
+            <a:avLst/>
+          </a:prstGeom>
+        </p:spPr>
+      </p:pic>
+      <p:sp>
+        <p:nvSpPr>
+          <p:cNvPr id="9" name="Espace réservé du numéro de diapositive 2">
+            <a:extLst>
+              <a:ext uri="{FF2B5EF4-FFF2-40B4-BE49-F238E27FC236}">
+                <a16:creationId xmlns:a16="http://schemas.microsoft.com/office/drawing/2014/main" id="{ECBEBDD9-D9CC-2B70-9E8C-523CC2893F62}"/>
+              </a:ext>
+            </a:extLst>
+          </p:cNvPr>
+          <p:cNvSpPr>
+            <a:spLocks noGrp="1"/>
+          </p:cNvSpPr>
+          <p:nvPr>
+            <p:ph type="sldNum" sz="quarter" idx="4"/>
+          </p:nvPr>
+        </p:nvSpPr>
+        <p:spPr/>
+        <p:txBody>
+          <a:bodyPr/>
+          <a:lstStyle/>
+          <a:p>
+            <a:fld id="{33C783E2-4793-4F48-A271-51A73CC37D74}" type="slidenum">
+              <a:rPr lang="fr-FR" smtClean="0"/>
+              <a:t>36</a:t>
+            </a:fld>
+            <a:endParaRPr lang="fr-FR"/>
+          </a:p>
+        </p:txBody>
+      </p:sp>
+      <p:sp>
+        <p:nvSpPr>
+          <p:cNvPr id="5" name="Repere de section"/>
+          <p:cNvSpPr txBox="1"/>
+          <p:nvPr/>
+        </p:nvSpPr>
+        <p:spPr>
+          <a:xfrm>
+            <a:off x="6583680" y="6382512"/>
+            <a:ext cx="4480560" cy="320040"/>
+          </a:xfrm>
+          <a:prstGeom prst="rect">
+            <a:avLst/>
+          </a:prstGeom>
+          <a:noFill/>
+        </p:spPr>
+        <p:txBody>
+          <a:bodyPr wrap="none" tIns="0" bIns="0">
+            <a:spAutoFit/>
+          </a:bodyPr>
+          <a:lstStyle/>
+          <a:p>
+            <a:pPr algn="r"/>
+            <a:r>
+              <a:rPr sz="1100">
+                <a:solidFill>
+                  <a:srgbClr val="BCBEC4"/>
+                </a:solidFill>
+              </a:rPr>
+              <a:t>COL · </a:t>
+            </a:r>
+            <a:r>
+              <a:rPr sz="1100" b="1">
+                <a:solidFill>
+                  <a:schemeClr val="accent4"/>
+                </a:solidFill>
+              </a:rPr>
+              <a:t>6. Comparer et trier</a:t>
+            </a:r>
+          </a:p>
+        </p:txBody>
+      </p:sp>
+    </p:spTree>
+  </p:cSld>
+  <p:clrMapOvr>
+    <a:masterClrMapping/>
+  </p:clrMapOvr>
 </p:sld>
 </file>
 

</xml_diff>